<commit_message>
Fix voice agent overlay disappearing, client error log, and dashboard syntax error
</commit_message>
<xml_diff>
--- a/SIH/Open_Innovation_Optimized.pptx
+++ b/SIH/Open_Innovation_Optimized.pptx
@@ -6397,7 +6397,7 @@
               <a:buChar char="•"/>
             </a:pPr>
             <a:r>
-              <a:rPr lang="en-US" sz="1300" dirty="0">
+              <a:rPr lang="en-US" sz="1150" dirty="0">
                 <a:solidFill>
                   <a:srgbClr val="4A5568"/>
                 </a:solidFill>
@@ -6405,7 +6405,7 @@
                 <a:ea typeface="Calibri" pitchFamily="34" charset="-122"/>
                 <a:cs typeface="Calibri" pitchFamily="34" charset="-120"/>
               </a:rPr>
-              <a:t>Offline-first RAG platform: local LLM (Ollama) + BAAI bge-large embeddings in ChromaDB ingest PDFs/DOCX, running entirely on the institution's server.</a:t>
+              <a:t>Offline-first RAG platform: local LLM (Ollama) + BAAI bge-large embeddings in ChromaDB generate cited, source-linked answers from uploaded PDFs/DOCX — running entirely on the institution's server.</a:t>
             </a:r>
             <a:endParaRPr lang="en-US" sz="1300" dirty="0"/>
           </a:p>
@@ -6418,7 +6418,7 @@
               <a:buChar char="•"/>
             </a:pPr>
             <a:r>
-              <a:rPr lang="en-US" sz="1300" dirty="0">
+              <a:rPr lang="en-US" sz="1150" dirty="0">
                 <a:solidFill>
                   <a:srgbClr val="4A5568"/>
                 </a:solidFill>
@@ -6426,7 +6426,7 @@
                 <a:ea typeface="Calibri" pitchFamily="34" charset="-122"/>
                 <a:cs typeface="Calibri" pitchFamily="34" charset="-120"/>
               </a:rPr>
-              <a:t>Auto-generates 6-day adaptive study sprints, mock tests, and flashcards from uploaded material.</a:t>
+              <a:t>Auto-generates FSRS-based spaced-repetition schedules, mock tests, and flashcards that adapt per student, per item.</a:t>
             </a:r>
             <a:endParaRPr lang="en-US" sz="1300" dirty="0"/>
           </a:p>
@@ -6439,7 +6439,7 @@
               <a:buChar char="•"/>
             </a:pPr>
             <a:r>
-              <a:rPr lang="en-US" sz="1300" dirty="0">
+              <a:rPr lang="en-US" sz="1150" dirty="0">
                 <a:solidFill>
                   <a:srgbClr val="4A5568"/>
                 </a:solidFill>
@@ -6447,7 +6447,7 @@
                 <a:ea typeface="Calibri" pitchFamily="34" charset="-122"/>
                 <a:cs typeface="Calibri" pitchFamily="34" charset="-120"/>
               </a:rPr>
-              <a:t>Interactive Voice AI Assistant (Web Speech API) for 24/7, hands-free tutoring and navigation.</a:t>
+              <a:t>Interactive Voice AI Assistant (Web Speech API) for 24/7 tutoring, navigation, and spoken audio-overview summaries of uploaded material.</a:t>
             </a:r>
             <a:endParaRPr lang="en-US" sz="1300" dirty="0"/>
           </a:p>
@@ -6460,7 +6460,7 @@
               <a:buChar char="•"/>
             </a:pPr>
             <a:r>
-              <a:rPr lang="en-US" sz="1300" dirty="0">
+              <a:rPr lang="en-US" sz="1150" dirty="0">
                 <a:solidFill>
                   <a:srgbClr val="4A5568"/>
                 </a:solidFill>
@@ -6468,7 +6468,7 @@
                 <a:ea typeface="Calibri" pitchFamily="34" charset="-122"/>
                 <a:cs typeface="Calibri" pitchFamily="34" charset="-120"/>
               </a:rPr>
-              <a:t>Biometric facial authentication for proctored exams; executive dashboard tracks live progress.</a:t>
+              <a:t>AI-powered webcam proctoring with face-presence detection for exams; executive dashboard tracks live progress.</a:t>
             </a:r>
             <a:endParaRPr lang="en-US" sz="1300" dirty="0"/>
           </a:p>
@@ -6481,7 +6481,7 @@
               <a:buChar char="•"/>
             </a:pPr>
             <a:r>
-              <a:rPr lang="en-US" sz="1300" dirty="0">
+              <a:rPr lang="en-US" sz="1150" dirty="0">
                 <a:solidFill>
                   <a:srgbClr val="4A5568"/>
                 </a:solidFill>
@@ -6773,7 +6773,7 @@
               <a:buNone/>
             </a:pPr>
             <a:r>
-              <a:rPr lang="en-US" sz="1600" b="1" dirty="0">
+              <a:rPr lang="en-US" sz="1500" b="1" dirty="0">
                 <a:solidFill>
                   <a:srgbClr val="1B2A4A"/>
                 </a:solidFill>
@@ -6781,7 +6781,7 @@
                 <a:ea typeface="Calibri" pitchFamily="34" charset="-122"/>
                 <a:cs typeface="Calibri" pitchFamily="34" charset="-120"/>
               </a:rPr>
-              <a:t>Manual proctored exams</a:t>
+              <a:t>NotebookLM / AI Notebook Tools</a:t>
             </a:r>
             <a:r>
               <a:rPr lang="en-US" sz="1150" b="1" dirty="0">
@@ -6796,7 +6796,7 @@
 </a:t>
             </a:r>
             <a:r>
-              <a:rPr lang="en-US" sz="1300" i="1" dirty="0">
+              <a:rPr lang="en-US" sz="1150" i="1" dirty="0">
                 <a:solidFill>
                   <a:srgbClr val="B23A3A"/>
                 </a:solidFill>
@@ -6804,11 +6804,11 @@
                 <a:ea typeface="Calibri" pitchFamily="34" charset="-122"/>
                 <a:cs typeface="Calibri" pitchFamily="34" charset="-120"/>
               </a:rPr>
-              <a:t>Gap: Labor-intensive, no real-time insight
+              <a:t>Gap: No proctoring or institutional dashboard
 </a:t>
             </a:r>
             <a:r>
-              <a:rPr lang="en-US" sz="1300" dirty="0">
+              <a:rPr lang="en-US" sz="1150" dirty="0">
                 <a:solidFill>
                   <a:srgbClr val="1F8A5F"/>
                 </a:solidFill>
@@ -6816,7 +6816,7 @@
                 <a:ea typeface="Calibri" pitchFamily="34" charset="-122"/>
                 <a:cs typeface="Calibri" pitchFamily="34" charset="-120"/>
               </a:rPr>
-              <a:t>Us: Biometric proctoring + live analytics dashboard</a:t>
+              <a:t>Us: Adds FSRS scheduling, proctoring, executive analytics</a:t>
             </a:r>
             <a:endParaRPr lang="en-US" sz="1300" dirty="0"/>
           </a:p>
@@ -7776,7 +7776,7 @@
                       <a:ea typeface="Calibri" pitchFamily="34" charset="-122"/>
                       <a:cs typeface="Calibri" pitchFamily="34" charset="-120"/>
                     </a:rPr>
-                    <a:t>(Vector Query)</a:t>
+                    <a:t>(Vector Query + Citations)</a:t>
                   </a:r>
                   <a:endParaRPr lang="en-US" sz="1100" dirty="0"/>
                 </a:p>
@@ -8034,7 +8034,7 @@
                       <a:ea typeface="Calibri" pitchFamily="34" charset="-122"/>
                       <a:cs typeface="Calibri" pitchFamily="34" charset="-120"/>
                     </a:rPr>
-                    <a:t>Study Sprints</a:t>
+                    <a:t>Adaptive Review</a:t>
                   </a:r>
                   <a:endParaRPr lang="en-US" sz="1100" dirty="0"/>
                 </a:p>
@@ -8051,7 +8051,7 @@
                       <a:ea typeface="Calibri" pitchFamily="34" charset="-122"/>
                       <a:cs typeface="Calibri" pitchFamily="34" charset="-120"/>
                     </a:rPr>
-                    <a:t>(Flashcards, Plans)</a:t>
+                    <a:t>(FSRS Engine)</a:t>
                   </a:r>
                   <a:endParaRPr lang="en-US" sz="1100" dirty="0"/>
                 </a:p>
@@ -8214,7 +8214,7 @@
                       <a:ea typeface="Calibri" pitchFamily="34" charset="-122"/>
                       <a:cs typeface="Calibri" pitchFamily="34" charset="-120"/>
                     </a:rPr>
-                    <a:t>Voice Responses</a:t>
+                    <a:t>Voice &amp; Audio</a:t>
                   </a:r>
                   <a:endParaRPr lang="en-US" sz="1100" dirty="0"/>
                 </a:p>
@@ -8231,7 +8231,7 @@
                       <a:ea typeface="Calibri" pitchFamily="34" charset="-122"/>
                       <a:cs typeface="Calibri" pitchFamily="34" charset="-120"/>
                     </a:rPr>
-                    <a:t>(TTS, Tutor)</a:t>
+                    <a:t>(TTS, Tutor, Overviews)</a:t>
                   </a:r>
                   <a:endParaRPr lang="en-US" sz="1100" dirty="0"/>
                 </a:p>
@@ -11253,7 +11253,7 @@
           <a:ln/>
         </p:spPr>
         <p:txBody>
-          <a:bodyPr wrap="square" lIns="0" tIns="0" rIns="0" bIns="0" rtlCol="0" anchor="ctr"/>
+          <a:bodyPr wrap="square" lIns="0" tIns="0" rIns="0" bIns="0" rtlCol="0" anchor="t"/>
           <a:lstStyle/>
           <a:p>
             <a:pPr marL="342900" indent="-342900">
@@ -11264,7 +11264,7 @@
               <a:buChar char="•"/>
             </a:pPr>
             <a:r>
-              <a:rPr lang="en-US" sz="1400" dirty="0">
+              <a:rPr lang="en-US" sz="1250" dirty="0">
                 <a:solidFill>
                   <a:srgbClr val="4A5568"/>
                 </a:solidFill>
@@ -11285,7 +11285,7 @@
               <a:buChar char="•"/>
             </a:pPr>
             <a:r>
-              <a:rPr lang="en-US" sz="1400" dirty="0">
+              <a:rPr lang="en-US" sz="1250" dirty="0">
                 <a:solidFill>
                   <a:srgbClr val="4A5568"/>
                 </a:solidFill>
@@ -11293,7 +11293,7 @@
                 <a:ea typeface="Calibri" pitchFamily="34" charset="-122"/>
                 <a:cs typeface="Calibri" pitchFamily="34" charset="-120"/>
               </a:rPr>
-              <a:t>Gives students personalized, adaptive 24/7 AI tutoring.</a:t>
+              <a:t>Gives students personalized, adaptive AI tutoring with FSRS-based retention scheduling.</a:t>
             </a:r>
             <a:endParaRPr lang="en-US" sz="1400" dirty="0"/>
           </a:p>
@@ -11306,7 +11306,7 @@
               <a:buChar char="•"/>
             </a:pPr>
             <a:r>
-              <a:rPr lang="en-US" sz="1400" dirty="0">
+              <a:rPr lang="en-US" sz="1250" dirty="0">
                 <a:solidFill>
                   <a:srgbClr val="4A5568"/>
                 </a:solidFill>
@@ -11327,7 +11327,7 @@
               <a:buChar char="•"/>
             </a:pPr>
             <a:r>
-              <a:rPr lang="en-US" sz="1400" dirty="0">
+              <a:rPr lang="en-US" sz="1250" dirty="0">
                 <a:solidFill>
                   <a:srgbClr val="4A5568"/>
                 </a:solidFill>
@@ -11348,7 +11348,7 @@
               <a:buChar char="•"/>
             </a:pPr>
             <a:r>
-              <a:rPr lang="en-US" sz="1400" dirty="0">
+              <a:rPr lang="en-US" sz="1250" dirty="0">
                 <a:solidFill>
                   <a:srgbClr val="4A5568"/>
                 </a:solidFill>
@@ -12557,409 +12557,6 @@
           </a:prstGeom>
         </p:spPr>
       </p:pic>
-      <p:grpSp>
-        <p:nvGrpSpPr>
-          <p:cNvPr id="42" name="Group 41">
-            <a:extLst>
-              <a:ext uri="{FF2B5EF4-FFF2-40B4-BE49-F238E27FC236}">
-                <a16:creationId xmlns:a16="http://schemas.microsoft.com/office/drawing/2014/main" id="{48920E9F-FB73-9FA1-D0A4-95DAB26EEA0C}"/>
-              </a:ext>
-            </a:extLst>
-          </p:cNvPr>
-          <p:cNvGrpSpPr/>
-          <p:nvPr/>
-        </p:nvGrpSpPr>
-        <p:grpSpPr>
-          <a:xfrm>
-            <a:off x="329773" y="1543894"/>
-            <a:ext cx="5112327" cy="966111"/>
-            <a:chOff x="365760" y="1737360"/>
-            <a:chExt cx="4937760" cy="658368"/>
-          </a:xfrm>
-        </p:grpSpPr>
-        <p:sp>
-          <p:nvSpPr>
-            <p:cNvPr id="3" name="Shape 8">
-              <a:extLst>
-                <a:ext uri="{FF2B5EF4-FFF2-40B4-BE49-F238E27FC236}">
-                  <a16:creationId xmlns:a16="http://schemas.microsoft.com/office/drawing/2014/main" id="{35BCB5B0-A355-F0DF-C9F3-DC06D31D6899}"/>
-                </a:ext>
-              </a:extLst>
-            </p:cNvPr>
-            <p:cNvSpPr/>
-            <p:nvPr/>
-          </p:nvSpPr>
-          <p:spPr>
-            <a:xfrm>
-              <a:off x="365760" y="1737360"/>
-              <a:ext cx="4937760" cy="658368"/>
-            </a:xfrm>
-            <a:prstGeom prst="roundRect">
-              <a:avLst>
-                <a:gd name="adj" fmla="val 8333"/>
-              </a:avLst>
-            </a:prstGeom>
-            <a:solidFill>
-              <a:srgbClr val="1B2A4A"/>
-            </a:solidFill>
-            <a:ln/>
-          </p:spPr>
-        </p:sp>
-        <p:sp>
-          <p:nvSpPr>
-            <p:cNvPr id="5" name="Text 9">
-              <a:extLst>
-                <a:ext uri="{FF2B5EF4-FFF2-40B4-BE49-F238E27FC236}">
-                  <a16:creationId xmlns:a16="http://schemas.microsoft.com/office/drawing/2014/main" id="{EA5CBF51-47FE-1CDD-B844-A0F9C3EBA0FE}"/>
-                </a:ext>
-              </a:extLst>
-            </p:cNvPr>
-            <p:cNvSpPr txBox="1"/>
-            <p:nvPr/>
-          </p:nvSpPr>
-          <p:spPr>
-            <a:xfrm>
-              <a:off x="365760" y="1792224"/>
-              <a:ext cx="4937760" cy="274320"/>
-            </a:xfrm>
-            <a:prstGeom prst="rect">
-              <a:avLst/>
-            </a:prstGeom>
-            <a:noFill/>
-            <a:ln/>
-          </p:spPr>
-          <p:txBody>
-            <a:bodyPr wrap="square" lIns="0" tIns="0" rIns="0" bIns="0" rtlCol="0" anchor="ctr"/>
-            <a:lstStyle/>
-            <a:p>
-              <a:pPr marL="0" indent="0" algn="ctr">
-                <a:buNone/>
-              </a:pPr>
-              <a:r>
-                <a:rPr lang="en-US" sz="1600" b="1" dirty="0">
-                  <a:solidFill>
-                    <a:srgbClr val="FFFFFF"/>
-                  </a:solidFill>
-                  <a:latin typeface="Calibri" pitchFamily="34" charset="0"/>
-                  <a:ea typeface="Calibri" pitchFamily="34" charset="-122"/>
-                  <a:cs typeface="Calibri" pitchFamily="34" charset="-120"/>
-                </a:rPr>
-                <a:t>TAM  $7.5B</a:t>
-              </a:r>
-              <a:endParaRPr lang="en-US" sz="1600" dirty="0"/>
-            </a:p>
-          </p:txBody>
-        </p:sp>
-        <p:sp>
-          <p:nvSpPr>
-            <p:cNvPr id="11" name="Text 10">
-              <a:extLst>
-                <a:ext uri="{FF2B5EF4-FFF2-40B4-BE49-F238E27FC236}">
-                  <a16:creationId xmlns:a16="http://schemas.microsoft.com/office/drawing/2014/main" id="{CEE25D90-77D8-FFE3-B31E-D7490C1F90F9}"/>
-                </a:ext>
-              </a:extLst>
-            </p:cNvPr>
-            <p:cNvSpPr txBox="1"/>
-            <p:nvPr/>
-          </p:nvSpPr>
-          <p:spPr>
-            <a:xfrm>
-              <a:off x="502920" y="2066544"/>
-              <a:ext cx="4663440" cy="292608"/>
-            </a:xfrm>
-            <a:prstGeom prst="rect">
-              <a:avLst/>
-            </a:prstGeom>
-            <a:noFill/>
-            <a:ln/>
-          </p:spPr>
-          <p:txBody>
-            <a:bodyPr wrap="square" lIns="0" tIns="0" rIns="0" bIns="0" rtlCol="0" anchor="ctr"/>
-            <a:lstStyle/>
-            <a:p>
-              <a:pPr marL="0" indent="0" algn="ctr">
-                <a:buNone/>
-              </a:pPr>
-              <a:r>
-                <a:rPr lang="en-US" sz="1600" dirty="0">
-                  <a:solidFill>
-                    <a:srgbClr val="E6EAF3"/>
-                  </a:solidFill>
-                  <a:latin typeface="Calibri" pitchFamily="34" charset="0"/>
-                  <a:ea typeface="Calibri" pitchFamily="34" charset="-122"/>
-                  <a:cs typeface="Calibri" pitchFamily="34" charset="-120"/>
-                </a:rPr>
-                <a:t>India EdTech market, 2025</a:t>
-              </a:r>
-              <a:endParaRPr lang="en-US" sz="1600" dirty="0"/>
-            </a:p>
-          </p:txBody>
-        </p:sp>
-      </p:grpSp>
-      <p:grpSp>
-        <p:nvGrpSpPr>
-          <p:cNvPr id="41" name="Group 40">
-            <a:extLst>
-              <a:ext uri="{FF2B5EF4-FFF2-40B4-BE49-F238E27FC236}">
-                <a16:creationId xmlns:a16="http://schemas.microsoft.com/office/drawing/2014/main" id="{7068E2BD-7714-84B3-8B27-7A8E920FE70B}"/>
-              </a:ext>
-            </a:extLst>
-          </p:cNvPr>
-          <p:cNvGrpSpPr/>
-          <p:nvPr/>
-        </p:nvGrpSpPr>
-        <p:grpSpPr>
-          <a:xfrm>
-            <a:off x="759956" y="2762168"/>
-            <a:ext cx="4251960" cy="1055714"/>
-            <a:chOff x="1051560" y="2523744"/>
-            <a:chExt cx="3566160" cy="658368"/>
-          </a:xfrm>
-        </p:grpSpPr>
-        <p:sp>
-          <p:nvSpPr>
-            <p:cNvPr id="14" name="Shape 11">
-              <a:extLst>
-                <a:ext uri="{FF2B5EF4-FFF2-40B4-BE49-F238E27FC236}">
-                  <a16:creationId xmlns:a16="http://schemas.microsoft.com/office/drawing/2014/main" id="{A534BC10-8F63-862F-C002-51478DF4FA27}"/>
-                </a:ext>
-              </a:extLst>
-            </p:cNvPr>
-            <p:cNvSpPr/>
-            <p:nvPr/>
-          </p:nvSpPr>
-          <p:spPr>
-            <a:xfrm>
-              <a:off x="1051560" y="2523744"/>
-              <a:ext cx="3566160" cy="658368"/>
-            </a:xfrm>
-            <a:prstGeom prst="roundRect">
-              <a:avLst>
-                <a:gd name="adj" fmla="val 8333"/>
-              </a:avLst>
-            </a:prstGeom>
-            <a:solidFill>
-              <a:srgbClr val="2E4A7A"/>
-            </a:solidFill>
-            <a:ln/>
-          </p:spPr>
-        </p:sp>
-        <p:sp>
-          <p:nvSpPr>
-            <p:cNvPr id="16" name="Text 12">
-              <a:extLst>
-                <a:ext uri="{FF2B5EF4-FFF2-40B4-BE49-F238E27FC236}">
-                  <a16:creationId xmlns:a16="http://schemas.microsoft.com/office/drawing/2014/main" id="{A4080F98-3952-9A23-80A6-57A170331800}"/>
-                </a:ext>
-              </a:extLst>
-            </p:cNvPr>
-            <p:cNvSpPr txBox="1"/>
-            <p:nvPr/>
-          </p:nvSpPr>
-          <p:spPr>
-            <a:xfrm>
-              <a:off x="1051560" y="2578608"/>
-              <a:ext cx="3566160" cy="274320"/>
-            </a:xfrm>
-            <a:prstGeom prst="rect">
-              <a:avLst/>
-            </a:prstGeom>
-            <a:noFill/>
-            <a:ln/>
-          </p:spPr>
-          <p:txBody>
-            <a:bodyPr wrap="square" lIns="0" tIns="0" rIns="0" bIns="0" rtlCol="0" anchor="ctr"/>
-            <a:lstStyle/>
-            <a:p>
-              <a:pPr marL="0" indent="0" algn="ctr">
-                <a:buNone/>
-              </a:pPr>
-              <a:r>
-                <a:rPr lang="en-US" sz="1600" b="1" dirty="0">
-                  <a:solidFill>
-                    <a:srgbClr val="FFFFFF"/>
-                  </a:solidFill>
-                  <a:latin typeface="Calibri" pitchFamily="34" charset="0"/>
-                  <a:ea typeface="Calibri" pitchFamily="34" charset="-122"/>
-                  <a:cs typeface="Calibri" pitchFamily="34" charset="-120"/>
-                </a:rPr>
-                <a:t>SAM  ~$1.1B</a:t>
-              </a:r>
-              <a:endParaRPr lang="en-US" sz="1600" dirty="0"/>
-            </a:p>
-          </p:txBody>
-        </p:sp>
-        <p:sp>
-          <p:nvSpPr>
-            <p:cNvPr id="18" name="Text 13">
-              <a:extLst>
-                <a:ext uri="{FF2B5EF4-FFF2-40B4-BE49-F238E27FC236}">
-                  <a16:creationId xmlns:a16="http://schemas.microsoft.com/office/drawing/2014/main" id="{AF059F8E-526D-E4F7-F94F-57B1F1D6102A}"/>
-                </a:ext>
-              </a:extLst>
-            </p:cNvPr>
-            <p:cNvSpPr txBox="1"/>
-            <p:nvPr/>
-          </p:nvSpPr>
-          <p:spPr>
-            <a:xfrm>
-              <a:off x="1188720" y="2852928"/>
-              <a:ext cx="3291840" cy="292608"/>
-            </a:xfrm>
-            <a:prstGeom prst="rect">
-              <a:avLst/>
-            </a:prstGeom>
-            <a:noFill/>
-            <a:ln/>
-          </p:spPr>
-          <p:txBody>
-            <a:bodyPr wrap="square" lIns="0" tIns="0" rIns="0" bIns="0" rtlCol="0" anchor="ctr"/>
-            <a:lstStyle/>
-            <a:p>
-              <a:pPr marL="0" indent="0" algn="ctr">
-                <a:buNone/>
-              </a:pPr>
-              <a:r>
-                <a:rPr lang="en-US" sz="1400" dirty="0">
-                  <a:solidFill>
-                    <a:srgbClr val="E6EAF3"/>
-                  </a:solidFill>
-                  <a:latin typeface="Calibri" pitchFamily="34" charset="0"/>
-                  <a:ea typeface="Calibri" pitchFamily="34" charset="-122"/>
-                  <a:cs typeface="Calibri" pitchFamily="34" charset="-120"/>
-                </a:rPr>
-                <a:t>Institutional AI-personalized learning &amp; LMS segment (~15% of TAM, est.)</a:t>
-              </a:r>
-              <a:endParaRPr lang="en-US" sz="1400" dirty="0"/>
-            </a:p>
-          </p:txBody>
-        </p:sp>
-      </p:grpSp>
-      <p:sp>
-        <p:nvSpPr>
-          <p:cNvPr id="20" name="Shape 14">
-            <a:extLst>
-              <a:ext uri="{FF2B5EF4-FFF2-40B4-BE49-F238E27FC236}">
-                <a16:creationId xmlns:a16="http://schemas.microsoft.com/office/drawing/2014/main" id="{BF306F62-46EE-9A45-A2FA-CAA7777EC56B}"/>
-              </a:ext>
-            </a:extLst>
-          </p:cNvPr>
-          <p:cNvSpPr/>
-          <p:nvPr/>
-        </p:nvSpPr>
-        <p:spPr>
-          <a:xfrm>
-            <a:off x="1518492" y="4005562"/>
-            <a:ext cx="2734887" cy="1056548"/>
-          </a:xfrm>
-          <a:prstGeom prst="roundRect">
-            <a:avLst>
-              <a:gd name="adj" fmla="val 8333"/>
-            </a:avLst>
-          </a:prstGeom>
-          <a:solidFill>
-            <a:schemeClr val="accent6">
-              <a:lumMod val="60000"/>
-              <a:lumOff val="40000"/>
-            </a:schemeClr>
-          </a:solidFill>
-          <a:ln/>
-        </p:spPr>
-      </p:sp>
-      <p:sp>
-        <p:nvSpPr>
-          <p:cNvPr id="22" name="Text 15">
-            <a:extLst>
-              <a:ext uri="{FF2B5EF4-FFF2-40B4-BE49-F238E27FC236}">
-                <a16:creationId xmlns:a16="http://schemas.microsoft.com/office/drawing/2014/main" id="{D57AE923-E286-8F74-DD1C-132805F5A562}"/>
-              </a:ext>
-            </a:extLst>
-          </p:cNvPr>
-          <p:cNvSpPr txBox="1"/>
-          <p:nvPr/>
-        </p:nvSpPr>
-        <p:spPr>
-          <a:xfrm>
-            <a:off x="1518492" y="4023431"/>
-            <a:ext cx="2734887" cy="440228"/>
-          </a:xfrm>
-          <a:prstGeom prst="rect">
-            <a:avLst/>
-          </a:prstGeom>
-          <a:solidFill>
-            <a:schemeClr val="accent6">
-              <a:lumMod val="60000"/>
-              <a:lumOff val="40000"/>
-            </a:schemeClr>
-          </a:solidFill>
-          <a:ln/>
-        </p:spPr>
-        <p:txBody>
-          <a:bodyPr wrap="square" lIns="0" tIns="0" rIns="0" bIns="0" rtlCol="0" anchor="ctr"/>
-          <a:lstStyle/>
-          <a:p>
-            <a:pPr marL="0" indent="0" algn="ctr">
-              <a:buNone/>
-            </a:pPr>
-            <a:r>
-              <a:rPr lang="en-US" sz="1600" b="1" dirty="0">
-                <a:latin typeface="Calibri" pitchFamily="34" charset="0"/>
-                <a:ea typeface="Calibri" pitchFamily="34" charset="-122"/>
-                <a:cs typeface="Calibri" pitchFamily="34" charset="-120"/>
-              </a:rPr>
-              <a:t>SOM  ~$0.3M</a:t>
-            </a:r>
-            <a:endParaRPr lang="en-US" sz="1600" dirty="0"/>
-          </a:p>
-        </p:txBody>
-      </p:sp>
-      <p:sp>
-        <p:nvSpPr>
-          <p:cNvPr id="24" name="Text 16">
-            <a:extLst>
-              <a:ext uri="{FF2B5EF4-FFF2-40B4-BE49-F238E27FC236}">
-                <a16:creationId xmlns:a16="http://schemas.microsoft.com/office/drawing/2014/main" id="{2BE2F41C-EE60-F785-547A-5F40E01606BB}"/>
-              </a:ext>
-            </a:extLst>
-          </p:cNvPr>
-          <p:cNvSpPr txBox="1"/>
-          <p:nvPr/>
-        </p:nvSpPr>
-        <p:spPr>
-          <a:xfrm>
-            <a:off x="1689422" y="4474047"/>
-            <a:ext cx="2393026" cy="469577"/>
-          </a:xfrm>
-          <a:prstGeom prst="rect">
-            <a:avLst/>
-          </a:prstGeom>
-          <a:solidFill>
-            <a:schemeClr val="accent6">
-              <a:lumMod val="60000"/>
-              <a:lumOff val="40000"/>
-            </a:schemeClr>
-          </a:solidFill>
-          <a:ln/>
-        </p:spPr>
-        <p:txBody>
-          <a:bodyPr wrap="square" lIns="0" tIns="0" rIns="0" bIns="0" rtlCol="0" anchor="ctr"/>
-          <a:lstStyle/>
-          <a:p>
-            <a:pPr marL="0" indent="0" algn="ctr">
-              <a:buNone/>
-            </a:pPr>
-            <a:r>
-              <a:rPr lang="en-US" sz="1400" dirty="0">
-                <a:latin typeface="Calibri" pitchFamily="34" charset="0"/>
-                <a:ea typeface="Calibri" pitchFamily="34" charset="-122"/>
-                <a:cs typeface="Calibri" pitchFamily="34" charset="-120"/>
-              </a:rPr>
-              <a:t>Year-1 reachable colleges/coaching institutes at ~1% conversion (est.)</a:t>
-            </a:r>
-            <a:endParaRPr lang="en-US" sz="1400" dirty="0"/>
-          </a:p>
-        </p:txBody>
-      </p:sp>
       <p:sp>
         <p:nvSpPr>
           <p:cNvPr id="26" name="Text 17">
@@ -12974,8 +12571,8 @@
         </p:nvSpPr>
         <p:spPr>
           <a:xfrm>
-            <a:off x="365760" y="5367528"/>
-            <a:ext cx="5394960" cy="502920"/>
+            <a:off x="365760" y="5320000"/>
+            <a:ext cx="5600000" cy="650000"/>
           </a:xfrm>
           <a:prstGeom prst="rect">
             <a:avLst/>
@@ -12999,7 +12596,7 @@
                 <a:ea typeface="Calibri" pitchFamily="34" charset="-122"/>
                 <a:cs typeface="Calibri" pitchFamily="34" charset="-120"/>
               </a:rPr>
-              <a:t>Source: IAMAI–Grant Thornton Bharat estimate via IBEF, 2025 (India EdTech market ≈ $7.5B). SAM/SOM are our own estimates – validate before citing externally.</a:t>
+              <a:t>Sources: TAM — IAMAI–Grant Thornton Bharat estimate via IBEF, 2025. SAM — IMARC Group, India LMS Market Report, 2025 (≈$877M, 15.39% CAGR to 2034). SOM is our own early-stage estimate — validate before citing externally.</a:t>
             </a:r>
             <a:endParaRPr lang="en-US" sz="1400" dirty="0"/>
           </a:p>
@@ -13108,7 +12705,7 @@
                 <a:ea typeface="Calibri" pitchFamily="34" charset="-122"/>
                 <a:cs typeface="Calibri" pitchFamily="34" charset="-120"/>
               </a:rPr>
-              <a:t>Cepeda et al., spacing-effect research underlying our 6-day adaptive sprints.
+              <a:t>Cepeda et al., spacing-effect research underlying our FSRS-based adaptive scheduling.
 </a:t>
             </a:r>
             <a:r>
@@ -13402,6 +12999,285 @@
           </p:txBody>
         </p:sp>
       </p:grpSp>
+      <p:sp>
+        <p:nvSpPr>
+          <p:cNvPr id="17410" name="Oval 17409"/>
+          <p:cNvSpPr/>
+          <p:nvPr/>
+        </p:nvSpPr>
+        <p:spPr>
+          <a:xfrm>
+            <a:off x="365760" y="1503840"/>
+            <a:ext cx="3566160" cy="3566160"/>
+          </a:xfrm>
+          <a:prstGeom prst="ellipse">
+            <a:avLst/>
+          </a:prstGeom>
+          <a:solidFill>
+            <a:srgbClr val="1B2A4A"/>
+          </a:solidFill>
+          <a:ln w="19050">
+            <a:solidFill>
+              <a:srgbClr val="FFFFFF"/>
+            </a:solidFill>
+          </a:ln>
+          <a:effectLst/>
+        </p:spPr>
+        <p:style>
+          <a:lnRef idx="1">
+            <a:schemeClr val="accent1"/>
+          </a:lnRef>
+          <a:fillRef idx="3">
+            <a:schemeClr val="accent1"/>
+          </a:fillRef>
+          <a:effectRef idx="2">
+            <a:schemeClr val="accent1"/>
+          </a:effectRef>
+          <a:fontRef idx="minor">
+            <a:schemeClr val="lt1"/>
+          </a:fontRef>
+        </p:style>
+        <p:txBody>
+          <a:bodyPr rtlCol="0" anchor="ctr"/>
+          <a:lstStyle/>
+          <a:p>
+            <a:pPr algn="ctr"/>
+          </a:p>
+        </p:txBody>
+      </p:sp>
+      <p:sp>
+        <p:nvSpPr>
+          <p:cNvPr id="17411" name="Oval 17410"/>
+          <p:cNvSpPr/>
+          <p:nvPr/>
+        </p:nvSpPr>
+        <p:spPr>
+          <a:xfrm>
+            <a:off x="960120" y="2692560"/>
+            <a:ext cx="2377440" cy="2377440"/>
+          </a:xfrm>
+          <a:prstGeom prst="ellipse">
+            <a:avLst/>
+          </a:prstGeom>
+          <a:solidFill>
+            <a:srgbClr val="2E4A7A"/>
+          </a:solidFill>
+          <a:ln w="19050">
+            <a:solidFill>
+              <a:srgbClr val="FFFFFF"/>
+            </a:solidFill>
+          </a:ln>
+          <a:effectLst/>
+        </p:spPr>
+        <p:style>
+          <a:lnRef idx="1">
+            <a:schemeClr val="accent1"/>
+          </a:lnRef>
+          <a:fillRef idx="3">
+            <a:schemeClr val="accent1"/>
+          </a:fillRef>
+          <a:effectRef idx="2">
+            <a:schemeClr val="accent1"/>
+          </a:effectRef>
+          <a:fontRef idx="minor">
+            <a:schemeClr val="lt1"/>
+          </a:fontRef>
+        </p:style>
+        <p:txBody>
+          <a:bodyPr rtlCol="0" anchor="ctr"/>
+          <a:lstStyle/>
+          <a:p>
+            <a:pPr algn="ctr"/>
+          </a:p>
+        </p:txBody>
+      </p:sp>
+      <p:sp>
+        <p:nvSpPr>
+          <p:cNvPr id="17412" name="Oval 17411"/>
+          <p:cNvSpPr/>
+          <p:nvPr/>
+        </p:nvSpPr>
+        <p:spPr>
+          <a:xfrm>
+            <a:off x="1554480" y="3881280"/>
+            <a:ext cx="1188720" cy="1188720"/>
+          </a:xfrm>
+          <a:prstGeom prst="ellipse">
+            <a:avLst/>
+          </a:prstGeom>
+          <a:solidFill>
+            <a:srgbClr val="F2A65C"/>
+          </a:solidFill>
+          <a:ln w="19050">
+            <a:solidFill>
+              <a:srgbClr val="FFFFFF"/>
+            </a:solidFill>
+          </a:ln>
+          <a:effectLst/>
+        </p:spPr>
+        <p:style>
+          <a:lnRef idx="1">
+            <a:schemeClr val="accent1"/>
+          </a:lnRef>
+          <a:fillRef idx="3">
+            <a:schemeClr val="accent1"/>
+          </a:fillRef>
+          <a:effectRef idx="2">
+            <a:schemeClr val="accent1"/>
+          </a:effectRef>
+          <a:fontRef idx="minor">
+            <a:schemeClr val="lt1"/>
+          </a:fontRef>
+        </p:style>
+        <p:txBody>
+          <a:bodyPr rtlCol="0" anchor="ctr"/>
+          <a:lstStyle/>
+          <a:p>
+            <a:pPr algn="ctr"/>
+          </a:p>
+        </p:txBody>
+      </p:sp>
+      <p:sp>
+        <p:nvSpPr>
+          <p:cNvPr id="17413" name="TextBox 17412"/>
+          <p:cNvSpPr txBox="1"/>
+          <p:nvPr/>
+        </p:nvSpPr>
+        <p:spPr>
+          <a:xfrm>
+            <a:off x="448840" y="1633840"/>
+            <a:ext cx="3400000" cy="700000"/>
+          </a:xfrm>
+          <a:prstGeom prst="rect">
+            <a:avLst/>
+          </a:prstGeom>
+          <a:noFill/>
+        </p:spPr>
+        <p:txBody>
+          <a:bodyPr wrap="square" lIns="0" rIns="0" tIns="0" bIns="0" anchor="t">
+            <a:spAutoFit/>
+          </a:bodyPr>
+          <a:lstStyle/>
+          <a:p>
+            <a:pPr algn="ctr"/>
+            <a:r>
+              <a:rPr sz="1800" b="1">
+                <a:solidFill>
+                  <a:srgbClr val="FFFFFF"/>
+                </a:solidFill>
+                <a:latin typeface="Calibri"/>
+              </a:rPr>
+              <a:t>TAM   $7.5B</a:t>
+            </a:r>
+          </a:p>
+          <a:p>
+            <a:pPr algn="ctr"/>
+            <a:r>
+              <a:rPr sz="1050" i="1">
+                <a:solidFill>
+                  <a:srgbClr val="C9D4E8"/>
+                </a:solidFill>
+                <a:latin typeface="Calibri"/>
+              </a:rPr>
+              <a:t>India EdTech market, 2025</a:t>
+            </a:r>
+          </a:p>
+        </p:txBody>
+      </p:sp>
+      <p:sp>
+        <p:nvSpPr>
+          <p:cNvPr id="17414" name="TextBox 17413"/>
+          <p:cNvSpPr txBox="1"/>
+          <p:nvPr/>
+        </p:nvSpPr>
+        <p:spPr>
+          <a:xfrm>
+            <a:off x="998840" y="2822560"/>
+            <a:ext cx="2300000" cy="700000"/>
+          </a:xfrm>
+          <a:prstGeom prst="rect">
+            <a:avLst/>
+          </a:prstGeom>
+          <a:noFill/>
+        </p:spPr>
+        <p:txBody>
+          <a:bodyPr wrap="square" lIns="0" rIns="0" tIns="0" bIns="0" anchor="t">
+            <a:spAutoFit/>
+          </a:bodyPr>
+          <a:lstStyle/>
+          <a:p>
+            <a:pPr algn="ctr"/>
+            <a:r>
+              <a:rPr sz="1500" b="1">
+                <a:solidFill>
+                  <a:srgbClr val="FFFFFF"/>
+                </a:solidFill>
+                <a:latin typeface="Calibri"/>
+              </a:rPr>
+              <a:t>SAM   $877M</a:t>
+            </a:r>
+          </a:p>
+          <a:p>
+            <a:pPr algn="ctr"/>
+            <a:r>
+              <a:rPr sz="950" i="1">
+                <a:solidFill>
+                  <a:srgbClr val="D6DEF0"/>
+                </a:solidFill>
+                <a:latin typeface="Calibri"/>
+              </a:rPr>
+              <a:t>India LMS market, 2025</a:t>
+            </a:r>
+          </a:p>
+        </p:txBody>
+      </p:sp>
+      <p:sp>
+        <p:nvSpPr>
+          <p:cNvPr id="17415" name="TextBox 17414"/>
+          <p:cNvSpPr txBox="1"/>
+          <p:nvPr/>
+        </p:nvSpPr>
+        <p:spPr>
+          <a:xfrm>
+            <a:off x="1558840" y="4265640"/>
+            <a:ext cx="1180000" cy="500000"/>
+          </a:xfrm>
+          <a:prstGeom prst="rect">
+            <a:avLst/>
+          </a:prstGeom>
+          <a:noFill/>
+        </p:spPr>
+        <p:txBody>
+          <a:bodyPr wrap="square" lIns="0" rIns="0" tIns="0" bIns="0" anchor="t">
+            <a:spAutoFit/>
+          </a:bodyPr>
+          <a:lstStyle/>
+          <a:p>
+            <a:pPr algn="ctr"/>
+            <a:r>
+              <a:rPr sz="1100" b="1">
+                <a:solidFill>
+                  <a:srgbClr val="1B2A4A"/>
+                </a:solidFill>
+                <a:latin typeface="Calibri"/>
+              </a:rPr>
+              <a:t>SOM</a:t>
+            </a:r>
+          </a:p>
+          <a:p>
+            <a:pPr algn="ctr"/>
+            <a:r>
+              <a:rPr sz="1300" i="1">
+                <a:solidFill>
+                  <a:srgbClr val="1B2A4A"/>
+                </a:solidFill>
+                <a:latin typeface="Calibri"/>
+              </a:rPr>
+              <a:t>~$0.3M</a:t>
+            </a:r>
+          </a:p>
+        </p:txBody>
+      </p:sp>
     </p:spTree>
     <p:extLst>
       <p:ext uri="{BB962C8B-B14F-4D97-AF65-F5344CB8AC3E}">

</xml_diff>